<commit_message>
Traps and movable bridges
</commit_message>
<xml_diff>
--- a/CtrlAltDelete.pptx
+++ b/CtrlAltDelete.pptx
@@ -115,6 +115,11 @@
       </a:defRPr>
     </a:lvl9pPr>
   </p:defaultTextStyle>
+  <p:extLst>
+    <p:ext uri="{EFAFB233-063F-42B5-8137-9DF3F51BA10A}">
+      <p15:sldGuideLst xmlns:p15="http://schemas.microsoft.com/office/powerpoint/2012/main"/>
+    </p:ext>
+  </p:extLst>
 </p:presentation>
 </file>
 
@@ -6184,7 +6189,7 @@
           <a:p>
             <a:fld id="{0B2B3672-7432-4912-8B7F-BDBF0D151904}" type="datetimeFigureOut">
               <a:rPr lang="cs-CZ" smtClean="0"/>
-              <a:t>23.01.2025</a:t>
+              <a:t>24.01.2025</a:t>
             </a:fld>
             <a:endParaRPr lang="cs-CZ"/>
           </a:p>
@@ -6682,7 +6687,7 @@
           <a:p>
             <a:fld id="{B247638D-23CB-4981-B536-5C764573447C}" type="datetimeFigureOut">
               <a:rPr lang="cs-CZ" smtClean="0"/>
-              <a:t>23.01.2025</a:t>
+              <a:t>24.01.2025</a:t>
             </a:fld>
             <a:endParaRPr lang="cs-CZ"/>
           </a:p>
@@ -6880,7 +6885,7 @@
           <a:p>
             <a:fld id="{B247638D-23CB-4981-B536-5C764573447C}" type="datetimeFigureOut">
               <a:rPr lang="cs-CZ" smtClean="0"/>
-              <a:t>23.01.2025</a:t>
+              <a:t>24.01.2025</a:t>
             </a:fld>
             <a:endParaRPr lang="cs-CZ"/>
           </a:p>
@@ -7088,7 +7093,7 @@
           <a:p>
             <a:fld id="{B247638D-23CB-4981-B536-5C764573447C}" type="datetimeFigureOut">
               <a:rPr lang="cs-CZ" smtClean="0"/>
-              <a:t>23.01.2025</a:t>
+              <a:t>24.01.2025</a:t>
             </a:fld>
             <a:endParaRPr lang="cs-CZ"/>
           </a:p>
@@ -7286,7 +7291,7 @@
           <a:p>
             <a:fld id="{B247638D-23CB-4981-B536-5C764573447C}" type="datetimeFigureOut">
               <a:rPr lang="cs-CZ" smtClean="0"/>
-              <a:t>23.01.2025</a:t>
+              <a:t>24.01.2025</a:t>
             </a:fld>
             <a:endParaRPr lang="cs-CZ"/>
           </a:p>
@@ -7561,7 +7566,7 @@
           <a:p>
             <a:fld id="{B247638D-23CB-4981-B536-5C764573447C}" type="datetimeFigureOut">
               <a:rPr lang="cs-CZ" smtClean="0"/>
-              <a:t>23.01.2025</a:t>
+              <a:t>24.01.2025</a:t>
             </a:fld>
             <a:endParaRPr lang="cs-CZ"/>
           </a:p>
@@ -7826,7 +7831,7 @@
           <a:p>
             <a:fld id="{B247638D-23CB-4981-B536-5C764573447C}" type="datetimeFigureOut">
               <a:rPr lang="cs-CZ" smtClean="0"/>
-              <a:t>23.01.2025</a:t>
+              <a:t>24.01.2025</a:t>
             </a:fld>
             <a:endParaRPr lang="cs-CZ"/>
           </a:p>
@@ -8238,7 +8243,7 @@
           <a:p>
             <a:fld id="{B247638D-23CB-4981-B536-5C764573447C}" type="datetimeFigureOut">
               <a:rPr lang="cs-CZ" smtClean="0"/>
-              <a:t>23.01.2025</a:t>
+              <a:t>24.01.2025</a:t>
             </a:fld>
             <a:endParaRPr lang="cs-CZ"/>
           </a:p>
@@ -8379,7 +8384,7 @@
           <a:p>
             <a:fld id="{B247638D-23CB-4981-B536-5C764573447C}" type="datetimeFigureOut">
               <a:rPr lang="cs-CZ" smtClean="0"/>
-              <a:t>23.01.2025</a:t>
+              <a:t>24.01.2025</a:t>
             </a:fld>
             <a:endParaRPr lang="cs-CZ"/>
           </a:p>
@@ -8492,7 +8497,7 @@
           <a:p>
             <a:fld id="{B247638D-23CB-4981-B536-5C764573447C}" type="datetimeFigureOut">
               <a:rPr lang="cs-CZ" smtClean="0"/>
-              <a:t>23.01.2025</a:t>
+              <a:t>24.01.2025</a:t>
             </a:fld>
             <a:endParaRPr lang="cs-CZ"/>
           </a:p>
@@ -8803,7 +8808,7 @@
           <a:p>
             <a:fld id="{B247638D-23CB-4981-B536-5C764573447C}" type="datetimeFigureOut">
               <a:rPr lang="cs-CZ" smtClean="0"/>
-              <a:t>23.01.2025</a:t>
+              <a:t>24.01.2025</a:t>
             </a:fld>
             <a:endParaRPr lang="cs-CZ"/>
           </a:p>
@@ -9091,7 +9096,7 @@
           <a:p>
             <a:fld id="{B247638D-23CB-4981-B536-5C764573447C}" type="datetimeFigureOut">
               <a:rPr lang="cs-CZ" smtClean="0"/>
-              <a:t>23.01.2025</a:t>
+              <a:t>24.01.2025</a:t>
             </a:fld>
             <a:endParaRPr lang="cs-CZ"/>
           </a:p>
@@ -9332,7 +9337,7 @@
           <a:p>
             <a:fld id="{B247638D-23CB-4981-B536-5C764573447C}" type="datetimeFigureOut">
               <a:rPr lang="cs-CZ" smtClean="0"/>
-              <a:t>23.01.2025</a:t>
+              <a:t>24.01.2025</a:t>
             </a:fld>
             <a:endParaRPr lang="cs-CZ"/>
           </a:p>
@@ -9862,7 +9867,7 @@
                   <a:spcPts val="600"/>
                 </a:spcAft>
               </a:pPr>
-              <a:t>1/23/2025</a:t>
+              <a:t>1/24/2025</a:t>
             </a:fld>
             <a:endParaRPr lang="en-US"/>
           </a:p>
@@ -10054,7 +10059,7 @@
                   <a:spcPts val="600"/>
                 </a:spcAft>
               </a:pPr>
-              <a:t>1/23/2025</a:t>
+              <a:t>1/24/2025</a:t>
             </a:fld>
             <a:endParaRPr lang="en-US"/>
           </a:p>
@@ -10256,7 +10261,7 @@
                   <a:spcPts val="600"/>
                 </a:spcAft>
               </a:pPr>
-              <a:t>1/23/2025</a:t>
+              <a:t>1/24/2025</a:t>
             </a:fld>
             <a:endParaRPr lang="en-US" dirty="0"/>
           </a:p>
@@ -10438,7 +10443,7 @@
           <a:p>
             <a:fld id="{2FB1DD93-7C9D-4E53-81F0-DDE57FEA7EDB}" type="datetime1">
               <a:rPr lang="en-US" smtClean="0"/>
-              <a:t>1/23/2025</a:t>
+              <a:t>1/24/2025</a:t>
             </a:fld>
             <a:endParaRPr lang="en-US"/>
           </a:p>
@@ -11042,7 +11047,7 @@
           <a:p>
             <a:fld id="{2FB1DD93-7C9D-4E53-81F0-DDE57FEA7EDB}" type="datetime1">
               <a:rPr lang="en-US" smtClean="0"/>
-              <a:t>1/23/2025</a:t>
+              <a:t>1/24/2025</a:t>
             </a:fld>
             <a:endParaRPr lang="en-US"/>
           </a:p>
@@ -11226,7 +11231,7 @@
           <a:p>
             <a:fld id="{0F88DB08-3B01-46DD-99F2-F6F6334EA669}" type="datetime1">
               <a:rPr lang="en-US" smtClean="0"/>
-              <a:t>1/23/2025</a:t>
+              <a:t>1/24/2025</a:t>
             </a:fld>
             <a:endParaRPr lang="en-US"/>
           </a:p>
@@ -11590,7 +11595,7 @@
             </a:pPr>
             <a:r>
               <a:rPr lang="cs-CZ" sz="1800" dirty="0"/>
-              <a:t>Textury – Lektvary, objekty pro hod, pasti…</a:t>
+              <a:t>Textury – Objekty pro hod, pasti, …</a:t>
             </a:r>
           </a:p>
           <a:p>
@@ -11600,7 +11605,7 @@
             </a:pPr>
             <a:r>
               <a:rPr lang="cs-CZ" sz="1800" dirty="0"/>
-              <a:t>Pouze jedna mapa ze tří - bez NAV </a:t>
+              <a:t>Pouze jedna mapa (nedodělaná) ze tří - bez NAV </a:t>
             </a:r>
             <a:r>
               <a:rPr lang="cs-CZ" sz="1800" dirty="0" err="1"/>
@@ -11617,6 +11622,17 @@
               <a:rPr lang="cs-CZ" sz="1800" dirty="0"/>
               <a:t>Posuvné, odrážející platformy nebo pasti</a:t>
             </a:r>
+          </a:p>
+          <a:p>
+            <a:pPr>
+              <a:buFontTx/>
+              <a:buChar char="-"/>
+            </a:pPr>
+            <a:r>
+              <a:rPr lang="cs-CZ" sz="1800" dirty="0"/>
+              <a:t>Zvuky</a:t>
+            </a:r>
+            <a:endParaRPr lang="cs-CZ" sz="1400" dirty="0"/>
           </a:p>
           <a:p>
             <a:pPr>
@@ -11650,7 +11666,7 @@
           <a:p>
             <a:fld id="{2FB1DD93-7C9D-4E53-81F0-DDE57FEA7EDB}" type="datetime1">
               <a:rPr lang="en-US" smtClean="0"/>
-              <a:t>1/23/2025</a:t>
+              <a:t>1/24/2025</a:t>
             </a:fld>
             <a:endParaRPr lang="en-US"/>
           </a:p>
@@ -11843,7 +11859,7 @@
                   <a:spcPts val="600"/>
                 </a:spcAft>
               </a:pPr>
-              <a:t>1/23/2025</a:t>
+              <a:t>1/24/2025</a:t>
             </a:fld>
             <a:endParaRPr lang="en-US"/>
           </a:p>
@@ -11997,7 +12013,7 @@
           <a:p>
             <a:fld id="{0F88DB08-3B01-46DD-99F2-F6F6334EA669}" type="datetime1">
               <a:rPr lang="en-US" smtClean="0"/>
-              <a:t>1/23/2025</a:t>
+              <a:t>1/24/2025</a:t>
             </a:fld>
             <a:endParaRPr lang="en-US"/>
           </a:p>

</xml_diff>